<commit_message>
updated slides and uploaded presentation video
</commit_message>
<xml_diff>
--- a/slides.pptx
+++ b/slides.pptx
@@ -5,17 +5,16 @@
     <p:sldMasterId id="2147483648" r:id="rId1"/>
   </p:sldMasterIdLst>
   <p:notesMasterIdLst>
-    <p:notesMasterId r:id="rId10"/>
+    <p:notesMasterId r:id="rId9"/>
   </p:notesMasterIdLst>
   <p:sldIdLst>
     <p:sldId id="256" r:id="rId2"/>
     <p:sldId id="257" r:id="rId3"/>
     <p:sldId id="258" r:id="rId4"/>
-    <p:sldId id="259" r:id="rId5"/>
-    <p:sldId id="260" r:id="rId6"/>
-    <p:sldId id="261" r:id="rId7"/>
-    <p:sldId id="262" r:id="rId8"/>
-    <p:sldId id="263" r:id="rId9"/>
+    <p:sldId id="260" r:id="rId5"/>
+    <p:sldId id="261" r:id="rId6"/>
+    <p:sldId id="262" r:id="rId7"/>
+    <p:sldId id="263" r:id="rId8"/>
   </p:sldIdLst>
   <p:sldSz cx="12192000" cy="6858000"/>
   <p:notesSz cx="6858000" cy="9144000"/>
@@ -114,6 +113,11 @@
       </a:defRPr>
     </a:lvl9pPr>
   </p:defaultTextStyle>
+  <p:extLst>
+    <p:ext uri="{EFAFB233-063F-42B5-8137-9DF3F51BA10A}">
+      <p15:sldGuideLst xmlns:p15="http://schemas.microsoft.com/office/powerpoint/2012/main"/>
+    </p:ext>
+  </p:extLst>
 </p:presentation>
 </file>
 
@@ -4384,322 +4388,6 @@
         <p:cNvPr id="1" name="">
           <a:extLst>
             <a:ext uri="{FF2B5EF4-FFF2-40B4-BE49-F238E27FC236}">
-              <a16:creationId xmlns:a16="http://schemas.microsoft.com/office/drawing/2014/main" id="{5A219B09-027E-31E6-6BB4-925DE2E126C3}"/>
-            </a:ext>
-          </a:extLst>
-        </p:cNvPr>
-        <p:cNvGrpSpPr/>
-        <p:nvPr/>
-      </p:nvGrpSpPr>
-      <p:grpSpPr>
-        <a:xfrm>
-          <a:off x="0" y="0"/>
-          <a:ext cx="0" cy="0"/>
-          <a:chOff x="0" y="0"/>
-          <a:chExt cx="0" cy="0"/>
-        </a:xfrm>
-      </p:grpSpPr>
-      <p:sp>
-        <p:nvSpPr>
-          <p:cNvPr id="2" name="标题 1">
-            <a:extLst>
-              <a:ext uri="{FF2B5EF4-FFF2-40B4-BE49-F238E27FC236}">
-                <a16:creationId xmlns:a16="http://schemas.microsoft.com/office/drawing/2014/main" id="{24564E74-A899-DBD4-BCB3-4ED29D2B6ABA}"/>
-              </a:ext>
-            </a:extLst>
-          </p:cNvPr>
-          <p:cNvSpPr>
-            <a:spLocks noGrp="1"/>
-          </p:cNvSpPr>
-          <p:nvPr>
-            <p:ph type="title"/>
-          </p:nvPr>
-        </p:nvSpPr>
-        <p:spPr/>
-        <p:txBody>
-          <a:bodyPr/>
-          <a:lstStyle/>
-          <a:p>
-            <a:r>
-              <a:rPr lang="en-US" altLang="zh-CN" dirty="0"/>
-              <a:t>What does the application do?</a:t>
-            </a:r>
-            <a:endParaRPr lang="zh-CN" altLang="en-US" dirty="0"/>
-          </a:p>
-        </p:txBody>
-      </p:sp>
-      <p:sp>
-        <p:nvSpPr>
-          <p:cNvPr id="5" name="Rectangle 2">
-            <a:extLst>
-              <a:ext uri="{FF2B5EF4-FFF2-40B4-BE49-F238E27FC236}">
-                <a16:creationId xmlns:a16="http://schemas.microsoft.com/office/drawing/2014/main" id="{9AB629E8-BD27-C8BC-B491-2F9CC792EC94}"/>
-              </a:ext>
-            </a:extLst>
-          </p:cNvPr>
-          <p:cNvSpPr>
-            <a:spLocks noGrp="1" noChangeArrowheads="1"/>
-          </p:cNvSpPr>
-          <p:nvPr>
-            <p:ph idx="1"/>
-          </p:nvPr>
-        </p:nvSpPr>
-        <p:spPr bwMode="auto">
-          <a:xfrm>
-            <a:off x="838200" y="2321004"/>
-            <a:ext cx="6266459" cy="2215991"/>
-          </a:xfrm>
-          <a:prstGeom prst="rect">
-            <a:avLst/>
-          </a:prstGeom>
-          <a:noFill/>
-          <a:ln>
-            <a:noFill/>
-          </a:ln>
-          <a:effectLst/>
-          <a:extLst>
-            <a:ext uri="{909E8E84-426E-40DD-AFC4-6F175D3DCCD1}">
-              <a14:hiddenFill xmlns:a14="http://schemas.microsoft.com/office/drawing/2010/main">
-                <a:solidFill>
-                  <a:schemeClr val="accent1"/>
-                </a:solidFill>
-              </a14:hiddenFill>
-            </a:ext>
-            <a:ext uri="{91240B29-F687-4F45-9708-019B960494DF}">
-              <a14:hiddenLine xmlns:a14="http://schemas.microsoft.com/office/drawing/2010/main" w="9525">
-                <a:solidFill>
-                  <a:schemeClr val="tx1"/>
-                </a:solidFill>
-                <a:miter lim="800000"/>
-                <a:headEnd/>
-                <a:tailEnd/>
-              </a14:hiddenLine>
-            </a:ext>
-            <a:ext uri="{AF507438-7753-43E0-B8FC-AC1667EBCBE1}">
-              <a14:hiddenEffects xmlns:a14="http://schemas.microsoft.com/office/drawing/2010/main">
-                <a:effectLst>
-                  <a:outerShdw dist="35921" dir="2700000" algn="ctr" rotWithShape="0">
-                    <a:schemeClr val="bg2"/>
-                  </a:outerShdw>
-                </a:effectLst>
-              </a14:hiddenEffects>
-            </a:ext>
-          </a:extLst>
-        </p:spPr>
-        <p:txBody>
-          <a:bodyPr vert="horz" wrap="none" lIns="91440" tIns="45720" rIns="91440" bIns="45720" numCol="1" anchor="ctr" anchorCtr="0" compatLnSpc="1">
-            <a:prstTxWarp prst="textNoShape">
-              <a:avLst/>
-            </a:prstTxWarp>
-            <a:spAutoFit/>
-          </a:bodyPr>
-          <a:lstStyle/>
-          <a:p>
-            <a:pPr marL="0" marR="0" lvl="0" indent="0" algn="l" defTabSz="914400" rtl="0" eaLnBrk="0" fontAlgn="base" latinLnBrk="0" hangingPunct="0">
-              <a:lnSpc>
-                <a:spcPct val="100000"/>
-              </a:lnSpc>
-              <a:spcBef>
-                <a:spcPct val="0"/>
-              </a:spcBef>
-              <a:spcAft>
-                <a:spcPct val="0"/>
-              </a:spcAft>
-              <a:buClrTx/>
-              <a:buSzTx/>
-              <a:buFontTx/>
-              <a:buNone/>
-              <a:tabLst/>
-            </a:pPr>
-            <a:endParaRPr kumimoji="0" lang="zh-CN" altLang="zh-CN" sz="1800" b="0" i="0" u="none" strike="noStrike" cap="none" normalizeH="0" baseline="0" dirty="0">
-              <a:ln>
-                <a:noFill/>
-              </a:ln>
-              <a:solidFill>
-                <a:schemeClr val="tx1"/>
-              </a:solidFill>
-              <a:effectLst/>
-              <a:latin typeface="Arial" panose="020B0604020202020204" pitchFamily="34" charset="0"/>
-            </a:endParaRPr>
-          </a:p>
-          <a:p>
-            <a:pPr marL="0" marR="0" lvl="0" indent="0" algn="l" defTabSz="914400" rtl="0" eaLnBrk="0" fontAlgn="base" latinLnBrk="0" hangingPunct="0">
-              <a:lnSpc>
-                <a:spcPct val="100000"/>
-              </a:lnSpc>
-              <a:spcBef>
-                <a:spcPct val="0"/>
-              </a:spcBef>
-              <a:spcAft>
-                <a:spcPct val="0"/>
-              </a:spcAft>
-              <a:buClrTx/>
-              <a:buSzTx/>
-              <a:buFontTx/>
-              <a:buChar char="•"/>
-              <a:tabLst/>
-            </a:pPr>
-            <a:r>
-              <a:rPr kumimoji="0" lang="zh-CN" altLang="zh-CN" sz="2400" b="0" i="0" u="none" strike="noStrike" cap="none" normalizeH="0" baseline="0" dirty="0">
-                <a:ln>
-                  <a:noFill/>
-                </a:ln>
-                <a:solidFill>
-                  <a:schemeClr val="tx1"/>
-                </a:solidFill>
-                <a:effectLst/>
-                <a:latin typeface="Arial" panose="020B0604020202020204" pitchFamily="34" charset="0"/>
-              </a:rPr>
-              <a:t>Find all reviews for a product </a:t>
-            </a:r>
-          </a:p>
-          <a:p>
-            <a:pPr marL="0" marR="0" lvl="0" indent="0" algn="l" defTabSz="914400" rtl="0" eaLnBrk="0" fontAlgn="base" latinLnBrk="0" hangingPunct="0">
-              <a:lnSpc>
-                <a:spcPct val="100000"/>
-              </a:lnSpc>
-              <a:spcBef>
-                <a:spcPct val="0"/>
-              </a:spcBef>
-              <a:spcAft>
-                <a:spcPct val="0"/>
-              </a:spcAft>
-              <a:buClrTx/>
-              <a:buSzTx/>
-              <a:buFontTx/>
-              <a:buChar char="•"/>
-              <a:tabLst/>
-            </a:pPr>
-            <a:r>
-              <a:rPr kumimoji="0" lang="zh-CN" altLang="zh-CN" sz="2400" b="0" i="0" u="none" strike="noStrike" cap="none" normalizeH="0" baseline="0" dirty="0">
-                <a:ln>
-                  <a:noFill/>
-                </a:ln>
-                <a:solidFill>
-                  <a:schemeClr val="tx1"/>
-                </a:solidFill>
-                <a:effectLst/>
-                <a:latin typeface="Arial" panose="020B0604020202020204" pitchFamily="34" charset="0"/>
-              </a:rPr>
-              <a:t>Find all reviews written by a user </a:t>
-            </a:r>
-          </a:p>
-          <a:p>
-            <a:pPr marL="0" marR="0" lvl="0" indent="0" algn="l" defTabSz="914400" rtl="0" eaLnBrk="0" fontAlgn="base" latinLnBrk="0" hangingPunct="0">
-              <a:lnSpc>
-                <a:spcPct val="100000"/>
-              </a:lnSpc>
-              <a:spcBef>
-                <a:spcPct val="0"/>
-              </a:spcBef>
-              <a:spcAft>
-                <a:spcPct val="0"/>
-              </a:spcAft>
-              <a:buClrTx/>
-              <a:buSzTx/>
-              <a:buFontTx/>
-              <a:buChar char="•"/>
-              <a:tabLst/>
-            </a:pPr>
-            <a:r>
-              <a:rPr kumimoji="0" lang="zh-CN" altLang="zh-CN" sz="2400" b="0" i="0" u="none" strike="noStrike" cap="none" normalizeH="0" baseline="0" dirty="0">
-                <a:ln>
-                  <a:noFill/>
-                </a:ln>
-                <a:solidFill>
-                  <a:schemeClr val="tx1"/>
-                </a:solidFill>
-                <a:effectLst/>
-                <a:latin typeface="Arial" panose="020B0604020202020204" pitchFamily="34" charset="0"/>
-              </a:rPr>
-              <a:t>Count how many reviews each product has </a:t>
-            </a:r>
-          </a:p>
-          <a:p>
-            <a:pPr marL="0" marR="0" lvl="0" indent="0" algn="l" defTabSz="914400" rtl="0" eaLnBrk="0" fontAlgn="base" latinLnBrk="0" hangingPunct="0">
-              <a:lnSpc>
-                <a:spcPct val="100000"/>
-              </a:lnSpc>
-              <a:spcBef>
-                <a:spcPct val="0"/>
-              </a:spcBef>
-              <a:spcAft>
-                <a:spcPct val="0"/>
-              </a:spcAft>
-              <a:buClrTx/>
-              <a:buSzTx/>
-              <a:buFontTx/>
-              <a:buChar char="•"/>
-              <a:tabLst/>
-            </a:pPr>
-            <a:r>
-              <a:rPr kumimoji="0" lang="zh-CN" altLang="zh-CN" sz="2400" b="0" i="0" u="none" strike="noStrike" cap="none" normalizeH="0" baseline="0" dirty="0">
-                <a:ln>
-                  <a:noFill/>
-                </a:ln>
-                <a:solidFill>
-                  <a:schemeClr val="tx1"/>
-                </a:solidFill>
-                <a:effectLst/>
-                <a:latin typeface="Arial" panose="020B0604020202020204" pitchFamily="34" charset="0"/>
-              </a:rPr>
-              <a:t>Count how many reviews each user has </a:t>
-            </a:r>
-          </a:p>
-          <a:p>
-            <a:pPr marL="0" marR="0" lvl="0" indent="0" algn="l" defTabSz="914400" rtl="0" eaLnBrk="0" fontAlgn="base" latinLnBrk="0" hangingPunct="0">
-              <a:lnSpc>
-                <a:spcPct val="100000"/>
-              </a:lnSpc>
-              <a:spcBef>
-                <a:spcPct val="0"/>
-              </a:spcBef>
-              <a:spcAft>
-                <a:spcPct val="0"/>
-              </a:spcAft>
-              <a:buClrTx/>
-              <a:buSzTx/>
-              <a:buFontTx/>
-              <a:buChar char="•"/>
-              <a:tabLst/>
-            </a:pPr>
-            <a:r>
-              <a:rPr kumimoji="0" lang="zh-CN" altLang="zh-CN" sz="2400" b="0" i="0" u="none" strike="noStrike" cap="none" normalizeH="0" baseline="0" dirty="0">
-                <a:ln>
-                  <a:noFill/>
-                </a:ln>
-                <a:solidFill>
-                  <a:schemeClr val="tx1"/>
-                </a:solidFill>
-                <a:effectLst/>
-                <a:latin typeface="Arial" panose="020B0604020202020204" pitchFamily="34" charset="0"/>
-              </a:rPr>
-              <a:t>Show overall score distribution </a:t>
-            </a:r>
-          </a:p>
-        </p:txBody>
-      </p:sp>
-    </p:spTree>
-    <p:extLst>
-      <p:ext uri="{BB962C8B-B14F-4D97-AF65-F5344CB8AC3E}">
-        <p14:creationId xmlns:p14="http://schemas.microsoft.com/office/powerpoint/2010/main" val="3181970633"/>
-      </p:ext>
-    </p:extLst>
-  </p:cSld>
-  <p:clrMapOvr>
-    <a:masterClrMapping/>
-  </p:clrMapOvr>
-</p:sld>
-</file>
-
-<file path=ppt/slides/slide5.xml><?xml version="1.0" encoding="utf-8"?>
-<p:sld xmlns:a="http://schemas.openxmlformats.org/drawingml/2006/main" xmlns:r="http://schemas.openxmlformats.org/officeDocument/2006/relationships" xmlns:p="http://schemas.openxmlformats.org/presentationml/2006/main">
-  <p:cSld>
-    <p:spTree>
-      <p:nvGrpSpPr>
-        <p:cNvPr id="1" name="">
-          <a:extLst>
-            <a:ext uri="{FF2B5EF4-FFF2-40B4-BE49-F238E27FC236}">
               <a16:creationId xmlns:a16="http://schemas.microsoft.com/office/drawing/2014/main" id="{22A5097A-37A6-4E41-C448-B62E01F55AA7}"/>
             </a:ext>
           </a:extLst>
@@ -4942,7 +4630,7 @@
 </p:sld>
 </file>
 
-<file path=ppt/slides/slide6.xml><?xml version="1.0" encoding="utf-8"?>
+<file path=ppt/slides/slide5.xml><?xml version="1.0" encoding="utf-8"?>
 <p:sld xmlns:a="http://schemas.openxmlformats.org/drawingml/2006/main" xmlns:r="http://schemas.openxmlformats.org/officeDocument/2006/relationships" xmlns:p="http://schemas.openxmlformats.org/presentationml/2006/main">
   <p:cSld>
     <p:spTree>
@@ -5226,7 +4914,7 @@
 </p:sld>
 </file>
 
-<file path=ppt/slides/slide7.xml><?xml version="1.0" encoding="utf-8"?>
+<file path=ppt/slides/slide6.xml><?xml version="1.0" encoding="utf-8"?>
 <p:sld xmlns:a="http://schemas.openxmlformats.org/drawingml/2006/main" xmlns:r="http://schemas.openxmlformats.org/officeDocument/2006/relationships" xmlns:p="http://schemas.openxmlformats.org/presentationml/2006/main">
   <p:cSld>
     <p:spTree>
@@ -5521,7 +5209,7 @@
 </p:sld>
 </file>
 
-<file path=ppt/slides/slide8.xml><?xml version="1.0" encoding="utf-8"?>
+<file path=ppt/slides/slide7.xml><?xml version="1.0" encoding="utf-8"?>
 <p:sld xmlns:a="http://schemas.openxmlformats.org/drawingml/2006/main" xmlns:r="http://schemas.openxmlformats.org/officeDocument/2006/relationships" xmlns:p="http://schemas.openxmlformats.org/presentationml/2006/main">
   <p:cSld>
     <p:spTree>

</xml_diff>